<commit_message>
fix: Add edits to presentation after second consultation
</commit_message>
<xml_diff>
--- a/rid_2026_seminarski/mi22035_Sofija_Janevska/prezentacija/Algoritamska manipulacija pažnjom.pptx
+++ b/rid_2026_seminarski/mi22035_Sofija_Janevska/prezentacija/Algoritamska manipulacija pažnjom.pptx
@@ -29,21 +29,22 @@
     <p:sldId id="277" r:id="rId27"/>
     <p:sldId id="278" r:id="rId28"/>
     <p:sldId id="279" r:id="rId29"/>
+    <p:sldId id="280" r:id="rId30"/>
   </p:sldIdLst>
   <p:sldSz cx="18288000" cy="10287000"/>
   <p:notesSz cx="6858000" cy="9144000"/>
   <p:embeddedFontLst>
     <p:embeddedFont>
       <p:font typeface="Poppins Bold" charset="1" panose="02000000000000000000"/>
-      <p:regular r:id="rId30"/>
+      <p:regular r:id="rId31"/>
     </p:embeddedFont>
     <p:embeddedFont>
       <p:font typeface="Poppins Light" charset="1" panose="02000000000000000000"/>
-      <p:regular r:id="rId31"/>
+      <p:regular r:id="rId32"/>
     </p:embeddedFont>
     <p:embeddedFont>
       <p:font typeface="Poppins Light Bold" charset="1" panose="02000000000000000000"/>
-      <p:regular r:id="rId32"/>
+      <p:regular r:id="rId33"/>
     </p:embeddedFont>
   </p:embeddedFontLst>
   <p:defaultTextStyle>
@@ -3498,7 +3499,7 @@
                 <a:cs typeface="Poppins Bold"/>
                 <a:sym typeface="Poppins Bold"/>
               </a:rPr>
-              <a:t>Collaborative filtering </a:t>
+              <a:t>Collaborative filtering: osnovna ideja</a:t>
             </a:r>
           </a:p>
         </p:txBody>
@@ -3511,8 +3512,8 @@
         </p:nvSpPr>
         <p:spPr>
           <a:xfrm rot="0">
-            <a:off x="414645" y="2051158"/>
-            <a:ext cx="17458711" cy="7410450"/>
+            <a:off x="414645" y="1950378"/>
+            <a:ext cx="17458711" cy="6838950"/>
           </a:xfrm>
           <a:prstGeom prst="rect">
             <a:avLst/>
@@ -3524,6 +3525,13 @@
           </a:bodyPr>
           <a:lstStyle/>
           <a:p>
+            <a:pPr algn="l">
+              <a:lnSpc>
+                <a:spcPts val="4500"/>
+              </a:lnSpc>
+            </a:pPr>
+          </a:p>
+          <a:p>
             <a:pPr algn="l" marL="647700" indent="-323850" lvl="1">
               <a:lnSpc>
                 <a:spcPts val="4500"/>
@@ -3544,8 +3552,18 @@
                 <a:cs typeface="Poppins Light"/>
                 <a:sym typeface="Poppins Light"/>
               </a:rPr>
-              <a:t>Umesto da sistem “razume” sam sadržaj u ljudskom smislu, on posmatra obrasce ponašanja velikog broja korisnika i iz tih obrazaca izvodi preporuke.</a:t>
-            </a:r>
+              <a:t>Umesto da sistem „razume” sadržaj u ljudskom smislu, on posmatra obrasce ponašanja velikog broja korisnika i iz tih obrazaca izvodi preporuke.</a:t>
+            </a:r>
+          </a:p>
+          <a:p>
+            <a:pPr algn="l">
+              <a:lnSpc>
+                <a:spcPts val="4500"/>
+              </a:lnSpc>
+              <a:spcBef>
+                <a:spcPct val="0"/>
+              </a:spcBef>
+            </a:pPr>
           </a:p>
           <a:p>
             <a:pPr algn="l" marL="647700" indent="-323850" lvl="1">
@@ -3568,7 +3586,7 @@
                 <a:cs typeface="Poppins Light"/>
                 <a:sym typeface="Poppins Light"/>
               </a:rPr>
-              <a:t>Sistem je zasnovan na matrici:</a:t>
+              <a:t>Sistem se može predstaviti matricom:</a:t>
             </a:r>
           </a:p>
           <a:p>
@@ -3592,7 +3610,89 @@
                 <a:cs typeface="Poppins Light"/>
                 <a:sym typeface="Poppins Light"/>
               </a:rPr>
-              <a:t>red &lt;-&gt; korisnik, kolona &lt;-&gt; konkretan sadržaj;</a:t>
+              <a:t>red = korisnik</a:t>
+            </a:r>
+          </a:p>
+          <a:p>
+            <a:pPr algn="l" marL="1943100" indent="-485775" lvl="3">
+              <a:lnSpc>
+                <a:spcPts val="4500"/>
+              </a:lnSpc>
+              <a:spcBef>
+                <a:spcPct val="0"/>
+              </a:spcBef>
+              <a:buFont typeface="Arial"/>
+              <a:buChar char="￭"/>
+            </a:pPr>
+            <a:r>
+              <a:rPr lang="en-US" sz="3000" spc="75" u="none">
+                <a:solidFill>
+                  <a:srgbClr val="DFD9F1"/>
+                </a:solidFill>
+                <a:latin typeface="Poppins Light"/>
+                <a:ea typeface="Poppins Light"/>
+                <a:cs typeface="Poppins Light"/>
+                <a:sym typeface="Poppins Light"/>
+              </a:rPr>
+              <a:t>kolona = konkretan sadržaj</a:t>
+            </a:r>
+          </a:p>
+          <a:p>
+            <a:pPr algn="l" marL="647700" indent="-323850" lvl="1">
+              <a:lnSpc>
+                <a:spcPts val="4500"/>
+              </a:lnSpc>
+              <a:spcBef>
+                <a:spcPct val="0"/>
+              </a:spcBef>
+              <a:buFont typeface="Arial"/>
+              <a:buChar char="•"/>
+            </a:pPr>
+            <a:r>
+              <a:rPr lang="en-US" sz="3000" spc="75" u="none">
+                <a:solidFill>
+                  <a:srgbClr val="DFD9F1"/>
+                </a:solidFill>
+                <a:latin typeface="Poppins Light"/>
+                <a:ea typeface="Poppins Light"/>
+                <a:cs typeface="Poppins Light"/>
+                <a:sym typeface="Poppins Light"/>
+              </a:rPr>
+              <a:t>vrednost polja = neki oblik korisničke reakcije</a:t>
+            </a:r>
+          </a:p>
+          <a:p>
+            <a:pPr algn="l">
+              <a:lnSpc>
+                <a:spcPts val="4500"/>
+              </a:lnSpc>
+              <a:spcBef>
+                <a:spcPct val="0"/>
+              </a:spcBef>
+            </a:pPr>
+          </a:p>
+          <a:p>
+            <a:pPr algn="l" marL="647700" indent="-323850" lvl="1">
+              <a:lnSpc>
+                <a:spcPts val="4500"/>
+              </a:lnSpc>
+              <a:spcBef>
+                <a:spcPct val="0"/>
+              </a:spcBef>
+              <a:buFont typeface="Arial"/>
+              <a:buChar char="•"/>
+            </a:pPr>
+            <a:r>
+              <a:rPr lang="en-US" sz="3000" spc="75" u="none">
+                <a:solidFill>
+                  <a:srgbClr val="DFD9F1"/>
+                </a:solidFill>
+                <a:latin typeface="Poppins Light"/>
+                <a:ea typeface="Poppins Light"/>
+                <a:cs typeface="Poppins Light"/>
+                <a:sym typeface="Poppins Light"/>
+              </a:rPr>
+              <a:t>Reakcija može biti:</a:t>
             </a:r>
           </a:p>
           <a:p>
@@ -3616,31 +3716,7 @@
                 <a:cs typeface="Poppins Light"/>
                 <a:sym typeface="Poppins Light"/>
               </a:rPr>
-              <a:t>vrednost polja &lt;-&gt; neki oblik korisničke reakcije.</a:t>
-            </a:r>
-          </a:p>
-          <a:p>
-            <a:pPr algn="l" marL="647700" indent="-323850" lvl="1">
-              <a:lnSpc>
-                <a:spcPts val="4500"/>
-              </a:lnSpc>
-              <a:spcBef>
-                <a:spcPct val="0"/>
-              </a:spcBef>
-              <a:buFont typeface="Arial"/>
-              <a:buChar char="•"/>
-            </a:pPr>
-            <a:r>
-              <a:rPr lang="en-US" sz="3000" spc="75" u="none">
-                <a:solidFill>
-                  <a:srgbClr val="DFD9F1"/>
-                </a:solidFill>
-                <a:latin typeface="Poppins Light"/>
-                <a:ea typeface="Poppins Light"/>
-                <a:cs typeface="Poppins Light"/>
-                <a:sym typeface="Poppins Light"/>
-              </a:rPr>
-              <a:t>Reakcija može biti:</a:t>
+              <a:t>eksplicitna — ocena od jedne do pet zvezdica</a:t>
             </a:r>
           </a:p>
           <a:p>
@@ -3664,127 +3740,7 @@
                 <a:cs typeface="Poppins Light"/>
                 <a:sym typeface="Poppins Light"/>
               </a:rPr>
-              <a:t>eksplicitna — ocena od jedne do pet zvezdica;</a:t>
-            </a:r>
-          </a:p>
-          <a:p>
-            <a:pPr algn="l" marL="1295400" indent="-431800" lvl="2">
-              <a:lnSpc>
-                <a:spcPts val="4500"/>
-              </a:lnSpc>
-              <a:spcBef>
-                <a:spcPct val="0"/>
-              </a:spcBef>
-              <a:buFont typeface="Arial"/>
-              <a:buChar char="⚬"/>
-            </a:pPr>
-            <a:r>
-              <a:rPr lang="en-US" sz="3000" spc="75" u="none">
-                <a:solidFill>
-                  <a:srgbClr val="DFD9F1"/>
-                </a:solidFill>
-                <a:latin typeface="Poppins Light"/>
-                <a:ea typeface="Poppins Light"/>
-                <a:cs typeface="Poppins Light"/>
-                <a:sym typeface="Poppins Light"/>
-              </a:rPr>
-              <a:t>implicitna — vreme gledanja, klik, pregled stranice, kupovina... </a:t>
-            </a:r>
-          </a:p>
-          <a:p>
-            <a:pPr algn="l" marL="647700" indent="-323850" lvl="1">
-              <a:lnSpc>
-                <a:spcPts val="4500"/>
-              </a:lnSpc>
-              <a:spcBef>
-                <a:spcPct val="0"/>
-              </a:spcBef>
-              <a:buFont typeface="Arial"/>
-              <a:buChar char="•"/>
-            </a:pPr>
-            <a:r>
-              <a:rPr lang="en-US" sz="3000" spc="75" u="none">
-                <a:solidFill>
-                  <a:srgbClr val="DFD9F1"/>
-                </a:solidFill>
-                <a:latin typeface="Poppins Light"/>
-                <a:ea typeface="Poppins Light"/>
-                <a:cs typeface="Poppins Light"/>
-                <a:sym typeface="Poppins Light"/>
-              </a:rPr>
-              <a:t>User-based collaborative filtering - kroz korisnike koji su slični posmatranom.</a:t>
-            </a:r>
-          </a:p>
-          <a:p>
-            <a:pPr algn="l" marL="647700" indent="-323850" lvl="1">
-              <a:lnSpc>
-                <a:spcPts val="4500"/>
-              </a:lnSpc>
-              <a:spcBef>
-                <a:spcPct val="0"/>
-              </a:spcBef>
-              <a:buFont typeface="Arial"/>
-              <a:buChar char="•"/>
-            </a:pPr>
-            <a:r>
-              <a:rPr lang="en-US" sz="3000" spc="75" u="none">
-                <a:solidFill>
-                  <a:srgbClr val="DFD9F1"/>
-                </a:solidFill>
-                <a:latin typeface="Poppins Light"/>
-                <a:ea typeface="Poppins Light"/>
-                <a:cs typeface="Poppins Light"/>
-                <a:sym typeface="Poppins Light"/>
-              </a:rPr>
-              <a:t>Item-based collaborative filtering - kroz obrasce uparenih pozitivnih reakcija.</a:t>
-            </a:r>
-          </a:p>
-          <a:p>
-            <a:pPr algn="l" marL="647700" indent="-323850" lvl="1">
-              <a:lnSpc>
-                <a:spcPts val="4500"/>
-              </a:lnSpc>
-              <a:spcBef>
-                <a:spcPct val="0"/>
-              </a:spcBef>
-              <a:buFont typeface="Arial"/>
-              <a:buChar char="•"/>
-            </a:pPr>
-            <a:r>
-              <a:rPr lang="en-US" sz="3000" spc="75" u="none">
-                <a:solidFill>
-                  <a:srgbClr val="DFD9F1"/>
-                </a:solidFill>
-                <a:latin typeface="Poppins Light"/>
-                <a:ea typeface="Poppins Light"/>
-                <a:cs typeface="Poppins Light"/>
-                <a:sym typeface="Poppins Light"/>
-              </a:rPr>
-              <a:t>U kontekstu engagementa, izbegava se “generalno popularan sadržaj”, preporuka je personalizovana.</a:t>
-            </a:r>
-          </a:p>
-          <a:p>
-            <a:pPr algn="l" marL="647700" indent="-323850" lvl="1">
-              <a:lnSpc>
-                <a:spcPts val="4500"/>
-              </a:lnSpc>
-              <a:spcBef>
-                <a:spcPct val="0"/>
-              </a:spcBef>
-              <a:buFont typeface="Arial"/>
-              <a:buChar char="•"/>
-            </a:pPr>
-            <a:r>
-              <a:rPr lang="en-US" sz="3000" spc="75" u="none">
-                <a:solidFill>
-                  <a:srgbClr val="DFD9F1"/>
-                </a:solidFill>
-                <a:latin typeface="Poppins Light"/>
-                <a:ea typeface="Poppins Light"/>
-                <a:cs typeface="Poppins Light"/>
-                <a:sym typeface="Poppins Light"/>
-              </a:rPr>
-              <a:t>Međutim, tu se otvaraju društveno problematične implikacije.</a:t>
+              <a:t>implicitna — vreme gledanja, klik, pregled stranice, kupovina...</a:t>
             </a:r>
           </a:p>
         </p:txBody>
@@ -3798,6 +3754,289 @@
 </file>
 
 <file path=ppt/slides/slide11.xml><?xml version="1.0" encoding="utf-8"?>
+<p:sld xmlns:p="http://schemas.openxmlformats.org/presentationml/2006/main" xmlns:a="http://schemas.openxmlformats.org/drawingml/2006/main">
+  <p:cSld>
+    <p:bg>
+      <p:bgPr>
+        <a:gradFill rotWithShape="true">
+          <a:gsLst>
+            <a:gs pos="0">
+              <a:srgbClr val="16117B">
+                <a:alpha val="100000"/>
+              </a:srgbClr>
+            </a:gs>
+            <a:gs pos="50000">
+              <a:srgbClr val="0B1244">
+                <a:alpha val="100000"/>
+              </a:srgbClr>
+            </a:gs>
+            <a:gs pos="100000">
+              <a:srgbClr val="000000">
+                <a:alpha val="100000"/>
+              </a:srgbClr>
+            </a:gs>
+          </a:gsLst>
+          <a:path path="circle">
+            <a:fillToRect l="50000" r="50000" t="50000" b="50000"/>
+          </a:path>
+        </a:gradFill>
+      </p:bgPr>
+    </p:bg>
+    <p:spTree>
+      <p:nvGrpSpPr>
+        <p:cNvPr id="1" name=""/>
+        <p:cNvGrpSpPr/>
+        <p:nvPr/>
+      </p:nvGrpSpPr>
+      <p:grpSpPr>
+        <a:xfrm>
+          <a:off x="0" y="0"/>
+          <a:ext cx="0" cy="0"/>
+          <a:chOff x="0" y="0"/>
+          <a:chExt cx="0" cy="0"/>
+        </a:xfrm>
+      </p:grpSpPr>
+      <p:sp>
+        <p:nvSpPr>
+          <p:cNvPr name="TextBox 2" id="2"/>
+          <p:cNvSpPr txBox="true"/>
+          <p:nvPr/>
+        </p:nvSpPr>
+        <p:spPr>
+          <a:xfrm rot="0">
+            <a:off x="691416" y="1038225"/>
+            <a:ext cx="16905168" cy="809625"/>
+          </a:xfrm>
+          <a:prstGeom prst="rect">
+            <a:avLst/>
+          </a:prstGeom>
+        </p:spPr>
+        <p:txBody>
+          <a:bodyPr anchor="t" rtlCol="false" tIns="0" lIns="0" bIns="0" rIns="0">
+            <a:spAutoFit/>
+          </a:bodyPr>
+          <a:lstStyle/>
+          <a:p>
+            <a:pPr algn="l" marL="0" indent="0" lvl="0">
+              <a:lnSpc>
+                <a:spcPts val="6480"/>
+              </a:lnSpc>
+              <a:spcBef>
+                <a:spcPct val="0"/>
+              </a:spcBef>
+            </a:pPr>
+            <a:r>
+              <a:rPr lang="en-US" sz="5400" spc="-135">
+                <a:solidFill>
+                  <a:srgbClr val="DFD9F1"/>
+                </a:solidFill>
+                <a:latin typeface="Poppins Bold"/>
+                <a:ea typeface="Poppins Bold"/>
+                <a:cs typeface="Poppins Bold"/>
+                <a:sym typeface="Poppins Bold"/>
+              </a:rPr>
+              <a:t>Dva pristupa u collaborative filtering-u</a:t>
+            </a:r>
+          </a:p>
+        </p:txBody>
+      </p:sp>
+      <p:sp>
+        <p:nvSpPr>
+          <p:cNvPr name="TextBox 3" id="3"/>
+          <p:cNvSpPr txBox="true"/>
+          <p:nvPr/>
+        </p:nvSpPr>
+        <p:spPr>
+          <a:xfrm rot="0">
+            <a:off x="414645" y="2757192"/>
+            <a:ext cx="17458711" cy="5124450"/>
+          </a:xfrm>
+          <a:prstGeom prst="rect">
+            <a:avLst/>
+          </a:prstGeom>
+        </p:spPr>
+        <p:txBody>
+          <a:bodyPr anchor="t" rtlCol="false" tIns="0" lIns="0" bIns="0" rIns="0">
+            <a:spAutoFit/>
+          </a:bodyPr>
+          <a:lstStyle/>
+          <a:p>
+            <a:pPr algn="l" marL="647700" indent="-323850" lvl="1">
+              <a:lnSpc>
+                <a:spcPts val="4500"/>
+              </a:lnSpc>
+              <a:buAutoNum type="arabicPeriod" startAt="1"/>
+            </a:pPr>
+            <a:r>
+              <a:rPr lang="en-US" sz="3000" spc="75">
+                <a:solidFill>
+                  <a:srgbClr val="DFD9F1"/>
+                </a:solidFill>
+                <a:latin typeface="Poppins Light"/>
+                <a:ea typeface="Poppins Light"/>
+                <a:cs typeface="Poppins Light"/>
+                <a:sym typeface="Poppins Light"/>
+              </a:rPr>
+              <a:t>User-based collaborative filtering</a:t>
+            </a:r>
+          </a:p>
+          <a:p>
+            <a:pPr algn="l">
+              <a:lnSpc>
+                <a:spcPts val="4500"/>
+              </a:lnSpc>
+            </a:pPr>
+            <a:r>
+              <a:rPr lang="en-US" sz="3000" spc="75">
+                <a:solidFill>
+                  <a:srgbClr val="DFD9F1"/>
+                </a:solidFill>
+                <a:latin typeface="Poppins Light"/>
+                <a:ea typeface="Poppins Light"/>
+                <a:cs typeface="Poppins Light"/>
+                <a:sym typeface="Poppins Light"/>
+              </a:rPr>
+              <a:t>            P</a:t>
+            </a:r>
+            <a:r>
+              <a:rPr lang="en-US" sz="3000" spc="75">
+                <a:solidFill>
+                  <a:srgbClr val="DFD9F1"/>
+                </a:solidFill>
+                <a:latin typeface="Poppins Light"/>
+                <a:ea typeface="Poppins Light"/>
+                <a:cs typeface="Poppins Light"/>
+                <a:sym typeface="Poppins Light"/>
+              </a:rPr>
+              <a:t>reporuke se izvode na osnovu korisnika koji su slični posmatranom korisniku.</a:t>
+            </a:r>
+          </a:p>
+          <a:p>
+            <a:pPr algn="l" marL="647700" indent="-323850" lvl="1">
+              <a:lnSpc>
+                <a:spcPts val="4500"/>
+              </a:lnSpc>
+              <a:buAutoNum type="arabicPeriod" startAt="1"/>
+            </a:pPr>
+            <a:r>
+              <a:rPr lang="en-US" sz="3000" spc="75">
+                <a:solidFill>
+                  <a:srgbClr val="DFD9F1"/>
+                </a:solidFill>
+                <a:latin typeface="Poppins Light"/>
+                <a:ea typeface="Poppins Light"/>
+                <a:cs typeface="Poppins Light"/>
+                <a:sym typeface="Poppins Light"/>
+              </a:rPr>
+              <a:t>Item-based collaborative filtering</a:t>
+            </a:r>
+          </a:p>
+          <a:p>
+            <a:pPr algn="l">
+              <a:lnSpc>
+                <a:spcPts val="4500"/>
+              </a:lnSpc>
+            </a:pPr>
+            <a:r>
+              <a:rPr lang="en-US" sz="3000" spc="75">
+                <a:solidFill>
+                  <a:srgbClr val="DFD9F1"/>
+                </a:solidFill>
+                <a:latin typeface="Poppins Light"/>
+                <a:ea typeface="Poppins Light"/>
+                <a:cs typeface="Poppins Light"/>
+                <a:sym typeface="Poppins Light"/>
+              </a:rPr>
+              <a:t>            P</a:t>
+            </a:r>
+            <a:r>
+              <a:rPr lang="en-US" sz="3000" spc="75">
+                <a:solidFill>
+                  <a:srgbClr val="DFD9F1"/>
+                </a:solidFill>
+                <a:latin typeface="Poppins Light"/>
+                <a:ea typeface="Poppins Light"/>
+                <a:cs typeface="Poppins Light"/>
+                <a:sym typeface="Poppins Light"/>
+              </a:rPr>
+              <a:t>reporuke se izvode na osnovu sadržaja/stavki koje dobijaju slične obrasce                                             .           pozitivnih reakcija.</a:t>
+            </a:r>
+          </a:p>
+          <a:p>
+            <a:pPr algn="l">
+              <a:lnSpc>
+                <a:spcPts val="4500"/>
+              </a:lnSpc>
+            </a:pPr>
+          </a:p>
+          <a:p>
+            <a:pPr algn="l" marL="647700" indent="-323850" lvl="1">
+              <a:lnSpc>
+                <a:spcPts val="4500"/>
+              </a:lnSpc>
+              <a:buFont typeface="Arial"/>
+              <a:buChar char="•"/>
+            </a:pPr>
+            <a:r>
+              <a:rPr lang="en-US" sz="3000" spc="75">
+                <a:solidFill>
+                  <a:srgbClr val="DFD9F1"/>
+                </a:solidFill>
+                <a:latin typeface="Poppins Light"/>
+                <a:ea typeface="Poppins Light"/>
+                <a:cs typeface="Poppins Light"/>
+                <a:sym typeface="Poppins Light"/>
+              </a:rPr>
+              <a:t>U kontekstu engagementa, cilj nije da se korisniku prikaže samo „generalno popularan” sadržaj, već sadržaj za koji sistem procenjuje da će baš njega zadržati.</a:t>
+            </a:r>
+          </a:p>
+          <a:p>
+            <a:pPr algn="l" marL="647700" indent="-323850" lvl="1">
+              <a:lnSpc>
+                <a:spcPts val="4500"/>
+              </a:lnSpc>
+              <a:spcBef>
+                <a:spcPct val="0"/>
+              </a:spcBef>
+              <a:buFont typeface="Arial"/>
+              <a:buChar char="•"/>
+            </a:pPr>
+            <a:r>
+              <a:rPr lang="en-US" sz="3000" spc="75">
+                <a:solidFill>
+                  <a:srgbClr val="DFD9F1"/>
+                </a:solidFill>
+                <a:latin typeface="Poppins Light"/>
+                <a:ea typeface="Poppins Light"/>
+                <a:cs typeface="Poppins Light"/>
+                <a:sym typeface="Poppins Light"/>
+              </a:rPr>
+              <a:t>U</a:t>
+            </a:r>
+            <a:r>
+              <a:rPr lang="en-US" sz="3000" spc="75">
+                <a:solidFill>
+                  <a:srgbClr val="DFD9F1"/>
+                </a:solidFill>
+                <a:latin typeface="Poppins Light"/>
+                <a:ea typeface="Poppins Light"/>
+                <a:cs typeface="Poppins Light"/>
+                <a:sym typeface="Poppins Light"/>
+              </a:rPr>
+              <a:t>pravo tu se otvaraju društveno problematične implikacije.</a:t>
+            </a:r>
+          </a:p>
+        </p:txBody>
+      </p:sp>
+    </p:spTree>
+  </p:cSld>
+  <p:clrMapOvr>
+    <a:masterClrMapping/>
+  </p:clrMapOvr>
+</p:sld>
+</file>
+
+<file path=ppt/slides/slide12.xml><?xml version="1.0" encoding="utf-8"?>
 <p:sld xmlns:p="http://schemas.openxmlformats.org/presentationml/2006/main" xmlns:a="http://schemas.openxmlformats.org/drawingml/2006/main" xmlns:r="http://schemas.openxmlformats.org/officeDocument/2006/relationships">
   <p:cSld>
     <p:bg>
@@ -4109,7 +4348,7 @@
 </p:sld>
 </file>
 
-<file path=ppt/slides/slide12.xml><?xml version="1.0" encoding="utf-8"?>
+<file path=ppt/slides/slide13.xml><?xml version="1.0" encoding="utf-8"?>
 <p:sld xmlns:p="http://schemas.openxmlformats.org/presentationml/2006/main" xmlns:a="http://schemas.openxmlformats.org/drawingml/2006/main">
   <p:cSld>
     <p:bg>
@@ -4355,7 +4594,7 @@
 </p:sld>
 </file>
 
-<file path=ppt/slides/slide13.xml><?xml version="1.0" encoding="utf-8"?>
+<file path=ppt/slides/slide14.xml><?xml version="1.0" encoding="utf-8"?>
 <p:sld xmlns:p="http://schemas.openxmlformats.org/presentationml/2006/main" xmlns:a="http://schemas.openxmlformats.org/drawingml/2006/main" xmlns:r="http://schemas.openxmlformats.org/officeDocument/2006/relationships">
   <p:cSld>
     <p:bg>
@@ -4648,7 +4887,7 @@
 </p:sld>
 </file>
 
-<file path=ppt/slides/slide14.xml><?xml version="1.0" encoding="utf-8"?>
+<file path=ppt/slides/slide15.xml><?xml version="1.0" encoding="utf-8"?>
 <p:sld xmlns:p="http://schemas.openxmlformats.org/presentationml/2006/main" xmlns:a="http://schemas.openxmlformats.org/drawingml/2006/main">
   <p:cSld>
     <p:bg>
@@ -4743,8 +4982,8 @@
         </p:nvSpPr>
         <p:spPr>
           <a:xfrm rot="0">
-            <a:off x="414645" y="2781675"/>
-            <a:ext cx="17458711" cy="4552950"/>
+            <a:off x="414645" y="2247900"/>
+            <a:ext cx="17458711" cy="5695950"/>
           </a:xfrm>
           <a:prstGeom prst="rect">
             <a:avLst/>
@@ -4878,7 +5117,7 @@
                 <a:cs typeface="Poppins Light"/>
                 <a:sym typeface="Poppins Light"/>
               </a:rPr>
-              <a:t>Konačni sud o promeni ne prepušta se intuiciji već, empirijskim podacima.</a:t>
+              <a:t>Konačni sud o promeni ne prepušta se intuiciji, već empirijskim podacima.</a:t>
             </a:r>
           </a:p>
           <a:p>
@@ -4906,6 +5145,16 @@
             </a:r>
           </a:p>
           <a:p>
+            <a:pPr algn="l">
+              <a:lnSpc>
+                <a:spcPts val="4500"/>
+              </a:lnSpc>
+              <a:spcBef>
+                <a:spcPct val="0"/>
+              </a:spcBef>
+            </a:pPr>
+          </a:p>
+          <a:p>
             <a:pPr algn="l" marL="647700" indent="-323850" lvl="1">
               <a:lnSpc>
                 <a:spcPts val="4500"/>
@@ -4926,8 +5175,18 @@
                 <a:cs typeface="Poppins Light"/>
                 <a:sym typeface="Poppins Light"/>
               </a:rPr>
-              <a:t>Ne znači da je svako A/B testiranje problematično, ali Izbor metrike?</a:t>
-            </a:r>
+              <a:t>Ne znači da je svako A/B testiranje problematično, ali da li je to izbor metrike?</a:t>
+            </a:r>
+          </a:p>
+          <a:p>
+            <a:pPr algn="l">
+              <a:lnSpc>
+                <a:spcPts val="4500"/>
+              </a:lnSpc>
+              <a:spcBef>
+                <a:spcPct val="0"/>
+              </a:spcBef>
+            </a:pPr>
           </a:p>
           <a:p>
             <a:pPr algn="l" marL="647700" indent="-323850" lvl="1">
@@ -4987,7 +5246,7 @@
 </p:sld>
 </file>
 
-<file path=ppt/slides/slide15.xml><?xml version="1.0" encoding="utf-8"?>
+<file path=ppt/slides/slide16.xml><?xml version="1.0" encoding="utf-8"?>
 <p:sld xmlns:p="http://schemas.openxmlformats.org/presentationml/2006/main" xmlns:a="http://schemas.openxmlformats.org/drawingml/2006/main" xmlns:r="http://schemas.openxmlformats.org/officeDocument/2006/relationships">
   <p:cSld>
     <p:bg>
@@ -5277,7 +5536,7 @@
 </p:sld>
 </file>
 
-<file path=ppt/slides/slide16.xml><?xml version="1.0" encoding="utf-8"?>
+<file path=ppt/slides/slide17.xml><?xml version="1.0" encoding="utf-8"?>
 <p:sld xmlns:p="http://schemas.openxmlformats.org/presentationml/2006/main" xmlns:a="http://schemas.openxmlformats.org/drawingml/2006/main">
   <p:cSld>
     <p:bg>
@@ -5620,7 +5879,7 @@
 </p:sld>
 </file>
 
-<file path=ppt/slides/slide17.xml><?xml version="1.0" encoding="utf-8"?>
+<file path=ppt/slides/slide18.xml><?xml version="1.0" encoding="utf-8"?>
 <p:sld xmlns:p="http://schemas.openxmlformats.org/presentationml/2006/main" xmlns:a="http://schemas.openxmlformats.org/drawingml/2006/main" xmlns:r="http://schemas.openxmlformats.org/officeDocument/2006/relationships">
   <p:cSld>
     <p:bg>
@@ -5868,356 +6127,6 @@
               </a:rPr>
               <a:t>Merenje pažnje</a:t>
             </a:r>
-          </a:p>
-        </p:txBody>
-      </p:sp>
-    </p:spTree>
-  </p:cSld>
-  <p:clrMapOvr>
-    <a:masterClrMapping/>
-  </p:clrMapOvr>
-</p:sld>
-</file>
-
-<file path=ppt/slides/slide18.xml><?xml version="1.0" encoding="utf-8"?>
-<p:sld xmlns:p="http://schemas.openxmlformats.org/presentationml/2006/main" xmlns:a="http://schemas.openxmlformats.org/drawingml/2006/main">
-  <p:cSld>
-    <p:bg>
-      <p:bgPr>
-        <a:gradFill rotWithShape="true">
-          <a:gsLst>
-            <a:gs pos="0">
-              <a:srgbClr val="16117B">
-                <a:alpha val="100000"/>
-              </a:srgbClr>
-            </a:gs>
-            <a:gs pos="50000">
-              <a:srgbClr val="0B1244">
-                <a:alpha val="100000"/>
-              </a:srgbClr>
-            </a:gs>
-            <a:gs pos="100000">
-              <a:srgbClr val="000000">
-                <a:alpha val="100000"/>
-              </a:srgbClr>
-            </a:gs>
-          </a:gsLst>
-          <a:path path="circle">
-            <a:fillToRect l="50000" r="50000" t="50000" b="50000"/>
-          </a:path>
-        </a:gradFill>
-      </p:bgPr>
-    </p:bg>
-    <p:spTree>
-      <p:nvGrpSpPr>
-        <p:cNvPr id="1" name=""/>
-        <p:cNvGrpSpPr/>
-        <p:nvPr/>
-      </p:nvGrpSpPr>
-      <p:grpSpPr>
-        <a:xfrm>
-          <a:off x="0" y="0"/>
-          <a:ext cx="0" cy="0"/>
-          <a:chOff x="0" y="0"/>
-          <a:chExt cx="0" cy="0"/>
-        </a:xfrm>
-      </p:grpSpPr>
-      <p:sp>
-        <p:nvSpPr>
-          <p:cNvPr name="TextBox 2" id="2"/>
-          <p:cNvSpPr txBox="true"/>
-          <p:nvPr/>
-        </p:nvSpPr>
-        <p:spPr>
-          <a:xfrm rot="0">
-            <a:off x="691416" y="1038225"/>
-            <a:ext cx="16905168" cy="809625"/>
-          </a:xfrm>
-          <a:prstGeom prst="rect">
-            <a:avLst/>
-          </a:prstGeom>
-        </p:spPr>
-        <p:txBody>
-          <a:bodyPr anchor="t" rtlCol="false" tIns="0" lIns="0" bIns="0" rIns="0">
-            <a:spAutoFit/>
-          </a:bodyPr>
-          <a:lstStyle/>
-          <a:p>
-            <a:pPr algn="l" marL="0" indent="0" lvl="0">
-              <a:lnSpc>
-                <a:spcPts val="6480"/>
-              </a:lnSpc>
-              <a:spcBef>
-                <a:spcPct val="0"/>
-              </a:spcBef>
-            </a:pPr>
-            <a:r>
-              <a:rPr lang="en-US" sz="5400" spc="-135">
-                <a:solidFill>
-                  <a:srgbClr val="DFD9F1"/>
-                </a:solidFill>
-                <a:latin typeface="Poppins Bold"/>
-                <a:ea typeface="Poppins Bold"/>
-                <a:cs typeface="Poppins Bold"/>
-                <a:sym typeface="Poppins Bold"/>
-              </a:rPr>
-              <a:t>Psihološki mehanizmi zadržavanja pažnje</a:t>
-            </a:r>
-          </a:p>
-        </p:txBody>
-      </p:sp>
-      <p:sp>
-        <p:nvSpPr>
-          <p:cNvPr name="TextBox 3" id="3"/>
-          <p:cNvSpPr txBox="true"/>
-          <p:nvPr/>
-        </p:nvSpPr>
-        <p:spPr>
-          <a:xfrm rot="0">
-            <a:off x="414645" y="2078718"/>
-            <a:ext cx="17458711" cy="7981950"/>
-          </a:xfrm>
-          <a:prstGeom prst="rect">
-            <a:avLst/>
-          </a:prstGeom>
-        </p:spPr>
-        <p:txBody>
-          <a:bodyPr anchor="t" rtlCol="false" tIns="0" lIns="0" bIns="0" rIns="0">
-            <a:spAutoFit/>
-          </a:bodyPr>
-          <a:lstStyle/>
-          <a:p>
-            <a:pPr algn="l" marL="647700" indent="-323850" lvl="1">
-              <a:lnSpc>
-                <a:spcPts val="4500"/>
-              </a:lnSpc>
-              <a:buFont typeface="Arial"/>
-              <a:buChar char="•"/>
-            </a:pPr>
-            <a:r>
-              <a:rPr lang="en-US" sz="3000" spc="75" u="none">
-                <a:solidFill>
-                  <a:srgbClr val="DFD9F1"/>
-                </a:solidFill>
-                <a:latin typeface="Poppins Light"/>
-                <a:ea typeface="Poppins Light"/>
-                <a:cs typeface="Poppins Light"/>
-                <a:sym typeface="Poppins Light"/>
-              </a:rPr>
-              <a:t>Tehnička optimizacija pažnje dela i van platforme, jer se prevodi u konkretne ko</a:t>
-            </a:r>
-            <a:r>
-              <a:rPr lang="en-US" sz="3000" spc="75" u="none">
-                <a:solidFill>
-                  <a:srgbClr val="DFD9F1"/>
-                </a:solidFill>
-                <a:latin typeface="Poppins Light"/>
-                <a:ea typeface="Poppins Light"/>
-                <a:cs typeface="Poppins Light"/>
-                <a:sym typeface="Poppins Light"/>
-              </a:rPr>
-              <a:t>risničke navike.</a:t>
-            </a:r>
-          </a:p>
-          <a:p>
-            <a:pPr algn="l" marL="647700" indent="-323850" lvl="1">
-              <a:lnSpc>
-                <a:spcPts val="4500"/>
-              </a:lnSpc>
-              <a:buFont typeface="Arial"/>
-              <a:buChar char="•"/>
-            </a:pPr>
-            <a:r>
-              <a:rPr lang="en-US" sz="3000" spc="75" u="none">
-                <a:solidFill>
-                  <a:srgbClr val="DFD9F1"/>
-                </a:solidFill>
-                <a:latin typeface="Poppins Light"/>
-                <a:ea typeface="Poppins Light"/>
-                <a:cs typeface="Poppins Light"/>
-                <a:sym typeface="Poppins Light"/>
-              </a:rPr>
-              <a:t>Npr. </a:t>
-            </a:r>
-            <a:r>
-              <a:rPr lang="en-US" sz="3000" spc="75" u="none">
-                <a:solidFill>
-                  <a:srgbClr val="DFD9F1"/>
-                </a:solidFill>
-                <a:latin typeface="Poppins Light"/>
-                <a:ea typeface="Poppins Light"/>
-                <a:cs typeface="Poppins Light"/>
-                <a:sym typeface="Poppins Light"/>
-              </a:rPr>
-              <a:t>konstantno proveravanje telefona, skrolovanje, sve teže prekidanje interakcije...</a:t>
-            </a:r>
-          </a:p>
-          <a:p>
-            <a:pPr algn="l" marL="647700" indent="-323850" lvl="1">
-              <a:lnSpc>
-                <a:spcPts val="4500"/>
-              </a:lnSpc>
-              <a:buFont typeface="Arial"/>
-              <a:buChar char="•"/>
-            </a:pPr>
-            <a:r>
-              <a:rPr lang="en-US" sz="3000" spc="75" u="none">
-                <a:solidFill>
-                  <a:srgbClr val="DFD9F1"/>
-                </a:solidFill>
-                <a:latin typeface="Poppins Light"/>
-                <a:ea typeface="Poppins Light"/>
-                <a:cs typeface="Poppins Light"/>
-                <a:sym typeface="Poppins Light"/>
-              </a:rPr>
-              <a:t>Korisnik nije potpuno autonoman akter pred neutralnim ekranom.</a:t>
-            </a:r>
-          </a:p>
-          <a:p>
-            <a:pPr algn="l" marL="647700" indent="-323850" lvl="1">
-              <a:lnSpc>
-                <a:spcPts val="4500"/>
-              </a:lnSpc>
-              <a:spcBef>
-                <a:spcPct val="0"/>
-              </a:spcBef>
-              <a:buFont typeface="Arial"/>
-              <a:buChar char="•"/>
-            </a:pPr>
-            <a:r>
-              <a:rPr lang="en-US" sz="3000" spc="75" u="none">
-                <a:solidFill>
-                  <a:srgbClr val="DFD9F1"/>
-                </a:solidFill>
-                <a:latin typeface="Poppins Light"/>
-                <a:ea typeface="Poppins Light"/>
-                <a:cs typeface="Poppins Light"/>
-                <a:sym typeface="Poppins Light"/>
-              </a:rPr>
-              <a:t>P</a:t>
-            </a:r>
-            <a:r>
-              <a:rPr lang="en-US" sz="3000" spc="75" u="none">
-                <a:solidFill>
-                  <a:srgbClr val="DFD9F1"/>
-                </a:solidFill>
-                <a:latin typeface="Poppins Light"/>
-                <a:ea typeface="Poppins Light"/>
-                <a:cs typeface="Poppins Light"/>
-                <a:sym typeface="Poppins Light"/>
-              </a:rPr>
-              <a:t>rostoru je dizajniran tako da prepoznaje njegove reakcije, slabosti, navike i emocionalne okidače.</a:t>
-            </a:r>
-          </a:p>
-          <a:p>
-            <a:pPr algn="l" marL="647700" indent="-323850" lvl="1">
-              <a:lnSpc>
-                <a:spcPts val="4500"/>
-              </a:lnSpc>
-              <a:spcBef>
-                <a:spcPct val="0"/>
-              </a:spcBef>
-              <a:buFont typeface="Arial"/>
-              <a:buChar char="•"/>
-            </a:pPr>
-            <a:r>
-              <a:rPr lang="en-US" sz="3000" spc="75" u="none">
-                <a:solidFill>
-                  <a:srgbClr val="DFD9F1"/>
-                </a:solidFill>
-                <a:latin typeface="Poppins Light"/>
-                <a:ea typeface="Poppins Light"/>
-                <a:cs typeface="Poppins Light"/>
-                <a:sym typeface="Poppins Light"/>
-              </a:rPr>
-              <a:t>Kada je cilj duže zadržavanje, češći povratak i intenzivnija reakcija, ps</a:t>
-            </a:r>
-            <a:r>
-              <a:rPr lang="en-US" sz="3000" spc="75" u="none">
-                <a:solidFill>
-                  <a:srgbClr val="DFD9F1"/>
-                </a:solidFill>
-                <a:latin typeface="Poppins Light"/>
-                <a:ea typeface="Poppins Light"/>
-                <a:cs typeface="Poppins Light"/>
-                <a:sym typeface="Poppins Light"/>
-              </a:rPr>
-              <a:t>ihologija prestaje da bude samo nauka o čoveku.</a:t>
-            </a:r>
-          </a:p>
-          <a:p>
-            <a:pPr algn="l">
-              <a:lnSpc>
-                <a:spcPts val="4500"/>
-              </a:lnSpc>
-              <a:spcBef>
-                <a:spcPct val="0"/>
-              </a:spcBef>
-            </a:pPr>
-          </a:p>
-          <a:p>
-            <a:pPr algn="ctr">
-              <a:lnSpc>
-                <a:spcPts val="4500"/>
-              </a:lnSpc>
-              <a:spcBef>
-                <a:spcPct val="0"/>
-              </a:spcBef>
-            </a:pPr>
-            <a:r>
-              <a:rPr lang="en-US" sz="3000" spc="75" u="none">
-                <a:solidFill>
-                  <a:srgbClr val="DFD9F1"/>
-                </a:solidFill>
-                <a:latin typeface="Poppins Light Bold"/>
-                <a:ea typeface="Poppins Light Bold"/>
-                <a:cs typeface="Poppins Light Bold"/>
-                <a:sym typeface="Poppins Light Bold"/>
-              </a:rPr>
-              <a:t>Problem nije u tome što platforme poznaju ljudsko ponašanje.</a:t>
-            </a:r>
-          </a:p>
-          <a:p>
-            <a:pPr algn="ctr">
-              <a:lnSpc>
-                <a:spcPts val="4500"/>
-              </a:lnSpc>
-              <a:spcBef>
-                <a:spcPct val="0"/>
-              </a:spcBef>
-            </a:pPr>
-            <a:r>
-              <a:rPr lang="en-US" sz="3000" spc="75" u="none">
-                <a:solidFill>
-                  <a:srgbClr val="DFD9F1"/>
-                </a:solidFill>
-                <a:latin typeface="Poppins Light Bold"/>
-                <a:ea typeface="Poppins Light Bold"/>
-                <a:cs typeface="Poppins Light Bold"/>
-                <a:sym typeface="Poppins Light Bold"/>
-              </a:rPr>
-              <a:t> Problem je u tome što se to znanje koristi unutar poslovnog modela u kome se korisnikova pažnja ne štiti, već eksploatiše.</a:t>
-            </a:r>
-          </a:p>
-          <a:p>
-            <a:pPr algn="l">
-              <a:lnSpc>
-                <a:spcPts val="4500"/>
-              </a:lnSpc>
-              <a:spcBef>
-                <a:spcPct val="0"/>
-              </a:spcBef>
-            </a:pPr>
-          </a:p>
-          <a:p>
-            <a:pPr algn="l">
-              <a:lnSpc>
-                <a:spcPts val="4500"/>
-              </a:lnSpc>
-              <a:spcBef>
-                <a:spcPct val="0"/>
-              </a:spcBef>
-            </a:pPr>
           </a:p>
         </p:txBody>
       </p:sp>
@@ -6311,7 +6220,7 @@
                 <a:cs typeface="Poppins Bold"/>
                 <a:sym typeface="Poppins Bold"/>
               </a:rPr>
-              <a:t>Promenljive nagrade i uklanjanje tačke prekida</a:t>
+              <a:t>Psihološki mehanizmi zadržavanja pažnje</a:t>
             </a:r>
           </a:p>
         </p:txBody>
@@ -6324,8 +6233,8 @@
         </p:nvSpPr>
         <p:spPr>
           <a:xfrm rot="0">
-            <a:off x="414645" y="2600640"/>
-            <a:ext cx="17458711" cy="5695950"/>
+            <a:off x="414645" y="2078718"/>
+            <a:ext cx="17458711" cy="7981950"/>
           </a:xfrm>
           <a:prstGeom prst="rect">
             <a:avLst/>
@@ -6345,16 +6254,28 @@
               <a:buChar char="•"/>
             </a:pPr>
             <a:r>
-              <a:rPr lang="en-US" sz="3000" spc="75">
-                <a:solidFill>
-                  <a:srgbClr val="DFD9F1"/>
-                </a:solidFill>
-                <a:latin typeface="Poppins Light"/>
-                <a:ea typeface="Poppins Light"/>
-                <a:cs typeface="Poppins Light"/>
-                <a:sym typeface="Poppins Light"/>
-              </a:rPr>
-              <a:t>Korisnik ne dolazi samo zbog sadržaja koji je već video, već zbog mogućnosti da sledeći sadržaj bude baš onaj koji će ga dotaći.</a:t>
+              <a:rPr lang="en-US" sz="3000" spc="75" u="none">
+                <a:solidFill>
+                  <a:srgbClr val="DFD9F1"/>
+                </a:solidFill>
+                <a:latin typeface="Poppins Light"/>
+                <a:ea typeface="Poppins Light"/>
+                <a:cs typeface="Poppins Light"/>
+                <a:sym typeface="Poppins Light"/>
+              </a:rPr>
+              <a:t>Tehnička optimizacija pažnje nastavlja se i van platforme, jer se prevodi u konkretne ko</a:t>
+            </a:r>
+            <a:r>
+              <a:rPr lang="en-US" sz="3000" spc="75" u="none">
+                <a:solidFill>
+                  <a:srgbClr val="DFD9F1"/>
+                </a:solidFill>
+                <a:latin typeface="Poppins Light"/>
+                <a:ea typeface="Poppins Light"/>
+                <a:cs typeface="Poppins Light"/>
+                <a:sym typeface="Poppins Light"/>
+              </a:rPr>
+              <a:t>risničke navike.</a:t>
             </a:r>
           </a:p>
           <a:p>
@@ -6366,24 +6287,29 @@
               <a:buChar char="•"/>
             </a:pPr>
             <a:r>
-              <a:rPr lang="en-US" sz="3000" spc="75">
-                <a:solidFill>
-                  <a:srgbClr val="DFD9F1"/>
-                </a:solidFill>
-                <a:latin typeface="Poppins Light"/>
-                <a:ea typeface="Poppins Light"/>
-                <a:cs typeface="Poppins Light"/>
-                <a:sym typeface="Poppins Light"/>
-              </a:rPr>
-              <a:t>Korisnik nastavlja ne zato što je svaki sadržaj vredan, već zato što sledeći možda jeste.</a:t>
-            </a:r>
-          </a:p>
-          <a:p>
-            <a:pPr algn="l">
-              <a:lnSpc>
-                <a:spcPts val="4500"/>
-              </a:lnSpc>
-            </a:pPr>
+              <a:rPr lang="en-US" sz="3000" spc="75" u="none">
+                <a:solidFill>
+                  <a:srgbClr val="DFD9F1"/>
+                </a:solidFill>
+                <a:latin typeface="Poppins Light"/>
+                <a:ea typeface="Poppins Light"/>
+                <a:cs typeface="Poppins Light"/>
+                <a:sym typeface="Poppins Light"/>
+              </a:rPr>
+              <a:t>Npr. </a:t>
+            </a:r>
+            <a:r>
+              <a:rPr lang="en-US" sz="3000" spc="75" u="none">
+                <a:solidFill>
+                  <a:srgbClr val="DFD9F1"/>
+                </a:solidFill>
+                <a:latin typeface="Poppins Light"/>
+                <a:ea typeface="Poppins Light"/>
+                <a:cs typeface="Poppins Light"/>
+                <a:sym typeface="Poppins Light"/>
+              </a:rPr>
+              <a:t>konstantno proveravanje telefona, skrolovanje, sve teže prekidanje interakcije...</a:t>
+            </a:r>
           </a:p>
           <a:p>
             <a:pPr algn="l" marL="647700" indent="-323850" lvl="1">
@@ -6394,16 +6320,16 @@
               <a:buChar char="•"/>
             </a:pPr>
             <a:r>
-              <a:rPr lang="en-US" sz="3000" spc="75">
-                <a:solidFill>
-                  <a:srgbClr val="DFD9F1"/>
-                </a:solidFill>
-                <a:latin typeface="Poppins Light"/>
-                <a:ea typeface="Poppins Light"/>
-                <a:cs typeface="Poppins Light"/>
-                <a:sym typeface="Poppins Light"/>
-              </a:rPr>
-              <a:t>Infinite scroll, autoplay i beskonačni feed uklanjaju trenutak u kome bi korisnik prirodno zastao i doneo odluku da prestane.</a:t>
+              <a:rPr lang="en-US" sz="3000" spc="75" u="none">
+                <a:solidFill>
+                  <a:srgbClr val="DFD9F1"/>
+                </a:solidFill>
+                <a:latin typeface="Poppins Light"/>
+                <a:ea typeface="Poppins Light"/>
+                <a:cs typeface="Poppins Light"/>
+                <a:sym typeface="Poppins Light"/>
+              </a:rPr>
+              <a:t>Korisnik nije potpuno autonoman akter pred neutralnim ekranom.</a:t>
             </a:r>
           </a:p>
           <a:p>
@@ -6418,17 +6344,129 @@
               <a:buChar char="•"/>
             </a:pPr>
             <a:r>
-              <a:rPr lang="en-US" sz="3000" spc="75">
-                <a:solidFill>
-                  <a:srgbClr val="DFD9F1"/>
-                </a:solidFill>
-                <a:latin typeface="Poppins Light"/>
-                <a:ea typeface="Poppins Light"/>
-                <a:cs typeface="Poppins Light"/>
-                <a:sym typeface="Poppins Light"/>
-              </a:rPr>
-              <a:t>Beskonačni tok sadržaja nije samo udobna funkcionalnost - On je arhitektura produženog ostanka.</a:t>
-            </a:r>
+              <a:rPr lang="en-US" sz="3000" spc="75" u="none">
+                <a:solidFill>
+                  <a:srgbClr val="DFD9F1"/>
+                </a:solidFill>
+                <a:latin typeface="Poppins Light"/>
+                <a:ea typeface="Poppins Light"/>
+                <a:cs typeface="Poppins Light"/>
+                <a:sym typeface="Poppins Light"/>
+              </a:rPr>
+              <a:t>P</a:t>
+            </a:r>
+            <a:r>
+              <a:rPr lang="en-US" sz="3000" spc="75" u="none">
+                <a:solidFill>
+                  <a:srgbClr val="DFD9F1"/>
+                </a:solidFill>
+                <a:latin typeface="Poppins Light"/>
+                <a:ea typeface="Poppins Light"/>
+                <a:cs typeface="Poppins Light"/>
+                <a:sym typeface="Poppins Light"/>
+              </a:rPr>
+              <a:t>rostor je dizajniran tako da prepoznaje njegove reakcije, slabosti, navike i emocionalne okidače.</a:t>
+            </a:r>
+          </a:p>
+          <a:p>
+            <a:pPr algn="l" marL="647700" indent="-323850" lvl="1">
+              <a:lnSpc>
+                <a:spcPts val="4500"/>
+              </a:lnSpc>
+              <a:spcBef>
+                <a:spcPct val="0"/>
+              </a:spcBef>
+              <a:buFont typeface="Arial"/>
+              <a:buChar char="•"/>
+            </a:pPr>
+            <a:r>
+              <a:rPr lang="en-US" sz="3000" spc="75" u="none">
+                <a:solidFill>
+                  <a:srgbClr val="DFD9F1"/>
+                </a:solidFill>
+                <a:latin typeface="Poppins Light"/>
+                <a:ea typeface="Poppins Light"/>
+                <a:cs typeface="Poppins Light"/>
+                <a:sym typeface="Poppins Light"/>
+              </a:rPr>
+              <a:t>Kada je cilj duže zadržavanje, češći povratak i intenzivnija reakcija, ps</a:t>
+            </a:r>
+            <a:r>
+              <a:rPr lang="en-US" sz="3000" spc="75" u="none">
+                <a:solidFill>
+                  <a:srgbClr val="DFD9F1"/>
+                </a:solidFill>
+                <a:latin typeface="Poppins Light"/>
+                <a:ea typeface="Poppins Light"/>
+                <a:cs typeface="Poppins Light"/>
+                <a:sym typeface="Poppins Light"/>
+              </a:rPr>
+              <a:t>ihologija prestaje da bude samo nauka o čoveku.</a:t>
+            </a:r>
+          </a:p>
+          <a:p>
+            <a:pPr algn="l">
+              <a:lnSpc>
+                <a:spcPts val="4500"/>
+              </a:lnSpc>
+              <a:spcBef>
+                <a:spcPct val="0"/>
+              </a:spcBef>
+            </a:pPr>
+          </a:p>
+          <a:p>
+            <a:pPr algn="ctr">
+              <a:lnSpc>
+                <a:spcPts val="4500"/>
+              </a:lnSpc>
+              <a:spcBef>
+                <a:spcPct val="0"/>
+              </a:spcBef>
+            </a:pPr>
+            <a:r>
+              <a:rPr lang="en-US" sz="3000" spc="75" u="none">
+                <a:solidFill>
+                  <a:srgbClr val="DFD9F1"/>
+                </a:solidFill>
+                <a:latin typeface="Poppins Light Bold"/>
+                <a:ea typeface="Poppins Light Bold"/>
+                <a:cs typeface="Poppins Light Bold"/>
+                <a:sym typeface="Poppins Light Bold"/>
+              </a:rPr>
+              <a:t>Problem nije u tome što platforme poznaju ljudsko ponašanje.</a:t>
+            </a:r>
+          </a:p>
+          <a:p>
+            <a:pPr algn="ctr">
+              <a:lnSpc>
+                <a:spcPts val="4500"/>
+              </a:lnSpc>
+              <a:spcBef>
+                <a:spcPct val="0"/>
+              </a:spcBef>
+            </a:pPr>
+            <a:r>
+              <a:rPr lang="en-US" sz="3000" spc="75" u="none">
+                <a:solidFill>
+                  <a:srgbClr val="DFD9F1"/>
+                </a:solidFill>
+                <a:latin typeface="Poppins Light Bold"/>
+                <a:ea typeface="Poppins Light Bold"/>
+                <a:cs typeface="Poppins Light Bold"/>
+                <a:sym typeface="Poppins Light Bold"/>
+              </a:rPr>
+              <a:t> Problem je u tome što se to znanje koristi unutar poslovnog modela u kome se korisnikova pažnja ne štiti, već eksploatiše.</a:t>
+            </a:r>
+          </a:p>
+          <a:p>
+            <a:pPr algn="l">
+              <a:lnSpc>
+                <a:spcPts val="4500"/>
+              </a:lnSpc>
+              <a:spcBef>
+                <a:spcPct val="0"/>
+              </a:spcBef>
+            </a:pPr>
           </a:p>
           <a:p>
             <a:pPr algn="l">
@@ -6995,7 +7033,7 @@
         <p:spPr>
           <a:xfrm rot="0">
             <a:off x="9204270" y="3460535"/>
-            <a:ext cx="8055030" cy="1097280"/>
+            <a:ext cx="8811435" cy="1097280"/>
           </a:xfrm>
           <a:prstGeom prst="rect">
             <a:avLst/>
@@ -7022,7 +7060,7 @@
                 <a:cs typeface="Poppins Light"/>
                 <a:sym typeface="Poppins Light"/>
               </a:rPr>
-              <a:t>Tehničke metode maksimizacija engagementa</a:t>
+              <a:t>Tehničke metode maksimizacije korisničkog angažovanja</a:t>
             </a:r>
           </a:p>
         </p:txBody>
@@ -7334,7 +7372,7 @@
                 <a:cs typeface="Poppins Bold"/>
                 <a:sym typeface="Poppins Bold"/>
               </a:rPr>
-              <a:t>Socijalna validacija, FOMO i emocionalni feed</a:t>
+              <a:t>Promenljive nagrade i uklanjanje tačke prekida</a:t>
             </a:r>
           </a:p>
         </p:txBody>
@@ -7347,8 +7385,8 @@
         </p:nvSpPr>
         <p:spPr>
           <a:xfrm rot="0">
-            <a:off x="414645" y="2419350"/>
-            <a:ext cx="17458711" cy="6838950"/>
+            <a:off x="414645" y="2600640"/>
+            <a:ext cx="17458711" cy="5695950"/>
           </a:xfrm>
           <a:prstGeom prst="rect">
             <a:avLst/>
@@ -7368,28 +7406,16 @@
               <a:buChar char="•"/>
             </a:pPr>
             <a:r>
-              <a:rPr lang="en-US" sz="3000" spc="75" u="none">
-                <a:solidFill>
-                  <a:srgbClr val="DFD9F1"/>
-                </a:solidFill>
-                <a:latin typeface="Poppins Light"/>
-                <a:ea typeface="Poppins Light"/>
-                <a:cs typeface="Poppins Light"/>
-                <a:sym typeface="Poppins Light"/>
-              </a:rPr>
-              <a:t>Platforma ne optimizuje samo odnos </a:t>
-            </a:r>
-            <a:r>
-              <a:rPr lang="en-US" sz="3000" spc="75" u="none">
-                <a:solidFill>
-                  <a:srgbClr val="DFD9F1"/>
-                </a:solidFill>
-                <a:latin typeface="Poppins Light"/>
-                <a:ea typeface="Poppins Light"/>
-                <a:cs typeface="Poppins Light"/>
-                <a:sym typeface="Poppins Light"/>
-              </a:rPr>
-              <a:t>korisnika prema sadržaju, već i njegov odnos prema drugim ljudima i samom sebi.</a:t>
+              <a:rPr lang="en-US" sz="3000" spc="75">
+                <a:solidFill>
+                  <a:srgbClr val="DFD9F1"/>
+                </a:solidFill>
+                <a:latin typeface="Poppins Light"/>
+                <a:ea typeface="Poppins Light"/>
+                <a:cs typeface="Poppins Light"/>
+                <a:sym typeface="Poppins Light"/>
+              </a:rPr>
+              <a:t>Korisnik ne dolazi samo zbog sadržaja koji je već video, već zbog mogućnosti da sledeći sadržaj bude baš onaj koji će ga dotaći.</a:t>
             </a:r>
           </a:p>
           <a:p>
@@ -7401,16 +7427,16 @@
               <a:buChar char="•"/>
             </a:pPr>
             <a:r>
-              <a:rPr lang="en-US" sz="3000" spc="75" u="none">
-                <a:solidFill>
-                  <a:srgbClr val="DFD9F1"/>
-                </a:solidFill>
-                <a:latin typeface="Poppins Light"/>
-                <a:ea typeface="Poppins Light"/>
-                <a:cs typeface="Poppins Light"/>
-                <a:sym typeface="Poppins Light"/>
-              </a:rPr>
-              <a:t>Lajkovi, komentari, deljenja, pregledi i pratioci mogu uticati na društveni status i/ili samovrednovanje.</a:t>
+              <a:rPr lang="en-US" sz="3000" spc="75">
+                <a:solidFill>
+                  <a:srgbClr val="DFD9F1"/>
+                </a:solidFill>
+                <a:latin typeface="Poppins Light"/>
+                <a:ea typeface="Poppins Light"/>
+                <a:cs typeface="Poppins Light"/>
+                <a:sym typeface="Poppins Light"/>
+              </a:rPr>
+              <a:t>Korisnik nastavlja ne zato što je svaki sadržaj vredan, već zato što sledeći možda jeste.</a:t>
             </a:r>
           </a:p>
           <a:p>
@@ -7425,23 +7451,20 @@
               <a:lnSpc>
                 <a:spcPts val="4500"/>
               </a:lnSpc>
-              <a:spcBef>
-                <a:spcPct val="0"/>
-              </a:spcBef>
               <a:buFont typeface="Arial"/>
               <a:buChar char="•"/>
             </a:pPr>
             <a:r>
-              <a:rPr lang="en-US" sz="3000" spc="75" u="none">
-                <a:solidFill>
-                  <a:srgbClr val="DFD9F1"/>
-                </a:solidFill>
-                <a:latin typeface="Poppins Light"/>
-                <a:ea typeface="Poppins Light"/>
-                <a:cs typeface="Poppins Light"/>
-                <a:sym typeface="Poppins Light"/>
-              </a:rPr>
-              <a:t>FOMO dodatno pojačava ovu dinamiku.</a:t>
+              <a:rPr lang="en-US" sz="3000" spc="75">
+                <a:solidFill>
+                  <a:srgbClr val="DFD9F1"/>
+                </a:solidFill>
+                <a:latin typeface="Poppins Light"/>
+                <a:ea typeface="Poppins Light"/>
+                <a:cs typeface="Poppins Light"/>
+                <a:sym typeface="Poppins Light"/>
+              </a:rPr>
+              <a:t>Infinite scroll, autoplay i beskonačni feed uklanjaju trenutak u kome bi korisnik prirodno zastao i doneo odluku da prestane.</a:t>
             </a:r>
           </a:p>
           <a:p>
@@ -7456,28 +7479,16 @@
               <a:buChar char="•"/>
             </a:pPr>
             <a:r>
-              <a:rPr lang="en-US" sz="3000" spc="75" u="none">
-                <a:solidFill>
-                  <a:srgbClr val="DFD9F1"/>
-                </a:solidFill>
-                <a:latin typeface="Poppins Light"/>
-                <a:ea typeface="Poppins Light"/>
-                <a:cs typeface="Poppins Light"/>
-                <a:sym typeface="Poppins Light"/>
-              </a:rPr>
-              <a:t>Platf</a:t>
-            </a:r>
-            <a:r>
-              <a:rPr lang="en-US" sz="3000" spc="75" u="none">
-                <a:solidFill>
-                  <a:srgbClr val="DFD9F1"/>
-                </a:solidFill>
-                <a:latin typeface="Poppins Light"/>
-                <a:ea typeface="Poppins Light"/>
-                <a:cs typeface="Poppins Light"/>
-                <a:sym typeface="Poppins Light"/>
-              </a:rPr>
-              <a:t>orma ne prodaje samo sadržaj, već osećaj da je odsustvo rizično.</a:t>
+              <a:rPr lang="en-US" sz="3000" spc="75">
+                <a:solidFill>
+                  <a:srgbClr val="DFD9F1"/>
+                </a:solidFill>
+                <a:latin typeface="Poppins Light"/>
+                <a:ea typeface="Poppins Light"/>
+                <a:cs typeface="Poppins Light"/>
+                <a:sym typeface="Poppins Light"/>
+              </a:rPr>
+              <a:t>Beskonačni tok sadržaja nije samo udobna funkcionalnost - On je arhitektura produženog ostanka.</a:t>
             </a:r>
           </a:p>
           <a:p>
@@ -7489,78 +7500,6 @@
                 <a:spcPct val="0"/>
               </a:spcBef>
             </a:pPr>
-          </a:p>
-          <a:p>
-            <a:pPr algn="l" marL="647700" indent="-323850" lvl="1">
-              <a:lnSpc>
-                <a:spcPts val="4500"/>
-              </a:lnSpc>
-              <a:spcBef>
-                <a:spcPct val="0"/>
-              </a:spcBef>
-              <a:buFont typeface="Arial"/>
-              <a:buChar char="•"/>
-            </a:pPr>
-            <a:r>
-              <a:rPr lang="en-US" sz="3000" spc="75" u="none">
-                <a:solidFill>
-                  <a:srgbClr val="DFD9F1"/>
-                </a:solidFill>
-                <a:latin typeface="Poppins Light"/>
-                <a:ea typeface="Poppins Light"/>
-                <a:cs typeface="Poppins Light"/>
-                <a:sym typeface="Poppins Light"/>
-              </a:rPr>
-              <a:t>Emocionalna promenljivost feed-a održava pažnju smenom prij</a:t>
-            </a:r>
-            <a:r>
-              <a:rPr lang="en-US" sz="3000" spc="75" u="none">
-                <a:solidFill>
-                  <a:srgbClr val="DFD9F1"/>
-                </a:solidFill>
-                <a:latin typeface="Poppins Light"/>
-                <a:ea typeface="Poppins Light"/>
-                <a:cs typeface="Poppins Light"/>
-                <a:sym typeface="Poppins Light"/>
-              </a:rPr>
-              <a:t>atnog, smešnog, tužnog, šokantnog, konfliktnog i intimnog sadržaja.</a:t>
-            </a:r>
-          </a:p>
-          <a:p>
-            <a:pPr algn="l" marL="647700" indent="-323850" lvl="1">
-              <a:lnSpc>
-                <a:spcPts val="4500"/>
-              </a:lnSpc>
-              <a:spcBef>
-                <a:spcPct val="0"/>
-              </a:spcBef>
-              <a:buFont typeface="Arial"/>
-              <a:buChar char="•"/>
-            </a:pPr>
-            <a:r>
-              <a:rPr lang="en-US" sz="3000" spc="75" u="none">
-                <a:solidFill>
-                  <a:srgbClr val="DFD9F1"/>
-                </a:solidFill>
-                <a:latin typeface="Poppins Light"/>
-                <a:ea typeface="Poppins Light"/>
-                <a:cs typeface="Poppins Light"/>
-                <a:sym typeface="Poppins Light"/>
-              </a:rPr>
-              <a:t>Takav f</a:t>
-            </a:r>
-            <a:r>
-              <a:rPr lang="en-US" sz="3000" spc="75" u="none">
-                <a:solidFill>
-                  <a:srgbClr val="DFD9F1"/>
-                </a:solidFill>
-                <a:latin typeface="Poppins Light"/>
-                <a:ea typeface="Poppins Light"/>
-                <a:cs typeface="Poppins Light"/>
-                <a:sym typeface="Poppins Light"/>
-              </a:rPr>
-              <a:t>eed je psihološki ritam podešen tako da korisnik ne potone u dosadu dovoljno dugo da bi aplikaciju zatvorio.</a:t>
-            </a:r>
           </a:p>
         </p:txBody>
       </p:sp>
@@ -7654,6 +7593,326 @@
                 <a:cs typeface="Poppins Bold"/>
                 <a:sym typeface="Poppins Bold"/>
               </a:rPr>
+              <a:t>Socijalna validacija, FOMO i emocionalni feed</a:t>
+            </a:r>
+          </a:p>
+        </p:txBody>
+      </p:sp>
+      <p:sp>
+        <p:nvSpPr>
+          <p:cNvPr name="TextBox 3" id="3"/>
+          <p:cNvSpPr txBox="true"/>
+          <p:nvPr/>
+        </p:nvSpPr>
+        <p:spPr>
+          <a:xfrm rot="0">
+            <a:off x="414645" y="2419350"/>
+            <a:ext cx="17458711" cy="6838950"/>
+          </a:xfrm>
+          <a:prstGeom prst="rect">
+            <a:avLst/>
+          </a:prstGeom>
+        </p:spPr>
+        <p:txBody>
+          <a:bodyPr anchor="t" rtlCol="false" tIns="0" lIns="0" bIns="0" rIns="0">
+            <a:spAutoFit/>
+          </a:bodyPr>
+          <a:lstStyle/>
+          <a:p>
+            <a:pPr algn="l" marL="647700" indent="-323850" lvl="1">
+              <a:lnSpc>
+                <a:spcPts val="4500"/>
+              </a:lnSpc>
+              <a:buFont typeface="Arial"/>
+              <a:buChar char="•"/>
+            </a:pPr>
+            <a:r>
+              <a:rPr lang="en-US" sz="3000" spc="75" u="none">
+                <a:solidFill>
+                  <a:srgbClr val="DFD9F1"/>
+                </a:solidFill>
+                <a:latin typeface="Poppins Light"/>
+                <a:ea typeface="Poppins Light"/>
+                <a:cs typeface="Poppins Light"/>
+                <a:sym typeface="Poppins Light"/>
+              </a:rPr>
+              <a:t>Platforma ne optimizuje samo odnos </a:t>
+            </a:r>
+            <a:r>
+              <a:rPr lang="en-US" sz="3000" spc="75" u="none">
+                <a:solidFill>
+                  <a:srgbClr val="DFD9F1"/>
+                </a:solidFill>
+                <a:latin typeface="Poppins Light"/>
+                <a:ea typeface="Poppins Light"/>
+                <a:cs typeface="Poppins Light"/>
+                <a:sym typeface="Poppins Light"/>
+              </a:rPr>
+              <a:t>korisnika prema sadržaju, već i njegov odnos prema drugim ljudima i samom sebi.</a:t>
+            </a:r>
+          </a:p>
+          <a:p>
+            <a:pPr algn="l" marL="647700" indent="-323850" lvl="1">
+              <a:lnSpc>
+                <a:spcPts val="4500"/>
+              </a:lnSpc>
+              <a:buFont typeface="Arial"/>
+              <a:buChar char="•"/>
+            </a:pPr>
+            <a:r>
+              <a:rPr lang="en-US" sz="3000" spc="75" u="none">
+                <a:solidFill>
+                  <a:srgbClr val="DFD9F1"/>
+                </a:solidFill>
+                <a:latin typeface="Poppins Light"/>
+                <a:ea typeface="Poppins Light"/>
+                <a:cs typeface="Poppins Light"/>
+                <a:sym typeface="Poppins Light"/>
+              </a:rPr>
+              <a:t>Lajkovi, komentari, deljenja, pregledi i pratioci mogu uticati na društveni status i/ili samovrednovanje.</a:t>
+            </a:r>
+          </a:p>
+          <a:p>
+            <a:pPr algn="l">
+              <a:lnSpc>
+                <a:spcPts val="4500"/>
+              </a:lnSpc>
+            </a:pPr>
+          </a:p>
+          <a:p>
+            <a:pPr algn="l" marL="647700" indent="-323850" lvl="1">
+              <a:lnSpc>
+                <a:spcPts val="4500"/>
+              </a:lnSpc>
+              <a:spcBef>
+                <a:spcPct val="0"/>
+              </a:spcBef>
+              <a:buFont typeface="Arial"/>
+              <a:buChar char="•"/>
+            </a:pPr>
+            <a:r>
+              <a:rPr lang="en-US" sz="3000" spc="75" u="none">
+                <a:solidFill>
+                  <a:srgbClr val="DFD9F1"/>
+                </a:solidFill>
+                <a:latin typeface="Poppins Light"/>
+                <a:ea typeface="Poppins Light"/>
+                <a:cs typeface="Poppins Light"/>
+                <a:sym typeface="Poppins Light"/>
+              </a:rPr>
+              <a:t>FOMO dodatno pojačava ovu dinamiku.</a:t>
+            </a:r>
+          </a:p>
+          <a:p>
+            <a:pPr algn="l" marL="647700" indent="-323850" lvl="1">
+              <a:lnSpc>
+                <a:spcPts val="4500"/>
+              </a:lnSpc>
+              <a:spcBef>
+                <a:spcPct val="0"/>
+              </a:spcBef>
+              <a:buFont typeface="Arial"/>
+              <a:buChar char="•"/>
+            </a:pPr>
+            <a:r>
+              <a:rPr lang="en-US" sz="3000" spc="75" u="none">
+                <a:solidFill>
+                  <a:srgbClr val="DFD9F1"/>
+                </a:solidFill>
+                <a:latin typeface="Poppins Light"/>
+                <a:ea typeface="Poppins Light"/>
+                <a:cs typeface="Poppins Light"/>
+                <a:sym typeface="Poppins Light"/>
+              </a:rPr>
+              <a:t>Platf</a:t>
+            </a:r>
+            <a:r>
+              <a:rPr lang="en-US" sz="3000" spc="75" u="none">
+                <a:solidFill>
+                  <a:srgbClr val="DFD9F1"/>
+                </a:solidFill>
+                <a:latin typeface="Poppins Light"/>
+                <a:ea typeface="Poppins Light"/>
+                <a:cs typeface="Poppins Light"/>
+                <a:sym typeface="Poppins Light"/>
+              </a:rPr>
+              <a:t>orma ne prodaje samo sadržaj, već osećaj da je odsustvo rizično.</a:t>
+            </a:r>
+          </a:p>
+          <a:p>
+            <a:pPr algn="l">
+              <a:lnSpc>
+                <a:spcPts val="4500"/>
+              </a:lnSpc>
+              <a:spcBef>
+                <a:spcPct val="0"/>
+              </a:spcBef>
+            </a:pPr>
+          </a:p>
+          <a:p>
+            <a:pPr algn="l" marL="647700" indent="-323850" lvl="1">
+              <a:lnSpc>
+                <a:spcPts val="4500"/>
+              </a:lnSpc>
+              <a:spcBef>
+                <a:spcPct val="0"/>
+              </a:spcBef>
+              <a:buFont typeface="Arial"/>
+              <a:buChar char="•"/>
+            </a:pPr>
+            <a:r>
+              <a:rPr lang="en-US" sz="3000" spc="75" u="none">
+                <a:solidFill>
+                  <a:srgbClr val="DFD9F1"/>
+                </a:solidFill>
+                <a:latin typeface="Poppins Light"/>
+                <a:ea typeface="Poppins Light"/>
+                <a:cs typeface="Poppins Light"/>
+                <a:sym typeface="Poppins Light"/>
+              </a:rPr>
+              <a:t>Emocionalna promenljivost feed-a održava pažnju smenom prij</a:t>
+            </a:r>
+            <a:r>
+              <a:rPr lang="en-US" sz="3000" spc="75" u="none">
+                <a:solidFill>
+                  <a:srgbClr val="DFD9F1"/>
+                </a:solidFill>
+                <a:latin typeface="Poppins Light"/>
+                <a:ea typeface="Poppins Light"/>
+                <a:cs typeface="Poppins Light"/>
+                <a:sym typeface="Poppins Light"/>
+              </a:rPr>
+              <a:t>atnog, smešnog, tužnog, šokantnog, konfliktnog i intimnog sadržaja.</a:t>
+            </a:r>
+          </a:p>
+          <a:p>
+            <a:pPr algn="l" marL="647700" indent="-323850" lvl="1">
+              <a:lnSpc>
+                <a:spcPts val="4500"/>
+              </a:lnSpc>
+              <a:spcBef>
+                <a:spcPct val="0"/>
+              </a:spcBef>
+              <a:buFont typeface="Arial"/>
+              <a:buChar char="•"/>
+            </a:pPr>
+            <a:r>
+              <a:rPr lang="en-US" sz="3000" spc="75" u="none">
+                <a:solidFill>
+                  <a:srgbClr val="DFD9F1"/>
+                </a:solidFill>
+                <a:latin typeface="Poppins Light"/>
+                <a:ea typeface="Poppins Light"/>
+                <a:cs typeface="Poppins Light"/>
+                <a:sym typeface="Poppins Light"/>
+              </a:rPr>
+              <a:t>Takav f</a:t>
+            </a:r>
+            <a:r>
+              <a:rPr lang="en-US" sz="3000" spc="75" u="none">
+                <a:solidFill>
+                  <a:srgbClr val="DFD9F1"/>
+                </a:solidFill>
+                <a:latin typeface="Poppins Light"/>
+                <a:ea typeface="Poppins Light"/>
+                <a:cs typeface="Poppins Light"/>
+                <a:sym typeface="Poppins Light"/>
+              </a:rPr>
+              <a:t>eed je psihološki ritam podešen tako da korisnik ne potone u dosadu dovoljno dugo da bi aplikaciju zatvorio.</a:t>
+            </a:r>
+          </a:p>
+        </p:txBody>
+      </p:sp>
+    </p:spTree>
+  </p:cSld>
+  <p:clrMapOvr>
+    <a:masterClrMapping/>
+  </p:clrMapOvr>
+</p:sld>
+</file>
+
+<file path=ppt/slides/slide22.xml><?xml version="1.0" encoding="utf-8"?>
+<p:sld xmlns:p="http://schemas.openxmlformats.org/presentationml/2006/main" xmlns:a="http://schemas.openxmlformats.org/drawingml/2006/main">
+  <p:cSld>
+    <p:bg>
+      <p:bgPr>
+        <a:gradFill rotWithShape="true">
+          <a:gsLst>
+            <a:gs pos="0">
+              <a:srgbClr val="16117B">
+                <a:alpha val="100000"/>
+              </a:srgbClr>
+            </a:gs>
+            <a:gs pos="50000">
+              <a:srgbClr val="0B1244">
+                <a:alpha val="100000"/>
+              </a:srgbClr>
+            </a:gs>
+            <a:gs pos="100000">
+              <a:srgbClr val="000000">
+                <a:alpha val="100000"/>
+              </a:srgbClr>
+            </a:gs>
+          </a:gsLst>
+          <a:path path="circle">
+            <a:fillToRect l="50000" r="50000" t="50000" b="50000"/>
+          </a:path>
+        </a:gradFill>
+      </p:bgPr>
+    </p:bg>
+    <p:spTree>
+      <p:nvGrpSpPr>
+        <p:cNvPr id="1" name=""/>
+        <p:cNvGrpSpPr/>
+        <p:nvPr/>
+      </p:nvGrpSpPr>
+      <p:grpSpPr>
+        <a:xfrm>
+          <a:off x="0" y="0"/>
+          <a:ext cx="0" cy="0"/>
+          <a:chOff x="0" y="0"/>
+          <a:chExt cx="0" cy="0"/>
+        </a:xfrm>
+      </p:grpSpPr>
+      <p:sp>
+        <p:nvSpPr>
+          <p:cNvPr name="TextBox 2" id="2"/>
+          <p:cNvSpPr txBox="true"/>
+          <p:nvPr/>
+        </p:nvSpPr>
+        <p:spPr>
+          <a:xfrm rot="0">
+            <a:off x="691416" y="1038225"/>
+            <a:ext cx="16905168" cy="809625"/>
+          </a:xfrm>
+          <a:prstGeom prst="rect">
+            <a:avLst/>
+          </a:prstGeom>
+        </p:spPr>
+        <p:txBody>
+          <a:bodyPr anchor="t" rtlCol="false" tIns="0" lIns="0" bIns="0" rIns="0">
+            <a:spAutoFit/>
+          </a:bodyPr>
+          <a:lstStyle/>
+          <a:p>
+            <a:pPr algn="l" marL="0" indent="0" lvl="0">
+              <a:lnSpc>
+                <a:spcPts val="6480"/>
+              </a:lnSpc>
+              <a:spcBef>
+                <a:spcPct val="0"/>
+              </a:spcBef>
+            </a:pPr>
+            <a:r>
+              <a:rPr lang="en-US" sz="5400" spc="-135">
+                <a:solidFill>
+                  <a:srgbClr val="DFD9F1"/>
+                </a:solidFill>
+                <a:latin typeface="Poppins Bold"/>
+                <a:ea typeface="Poppins Bold"/>
+                <a:cs typeface="Poppins Bold"/>
+                <a:sym typeface="Poppins Bold"/>
+              </a:rPr>
               <a:t>Navika ili digitalna adikcija?</a:t>
             </a:r>
           </a:p>
@@ -7756,7 +8015,7 @@
                 <a:cs typeface="Poppins Light"/>
                 <a:sym typeface="Poppins Light"/>
               </a:rPr>
-              <a:t>Digitalna</a:t>
+              <a:t>Da li je digitalna</a:t>
             </a:r>
             <a:r>
               <a:rPr lang="en-US" sz="3000" spc="75" u="none">
@@ -7768,7 +8027,7 @@
                 <a:cs typeface="Poppins Light"/>
                 <a:sym typeface="Poppins Light"/>
               </a:rPr>
-              <a:t> adikcija je slabosti pojedinca?</a:t>
+              <a:t> adikcija slabost pojedinca?</a:t>
             </a:r>
           </a:p>
           <a:p>
@@ -7897,7 +8156,7 @@
 </p:sld>
 </file>
 
-<file path=ppt/slides/slide22.xml><?xml version="1.0" encoding="utf-8"?>
+<file path=ppt/slides/slide23.xml><?xml version="1.0" encoding="utf-8"?>
 <p:sld xmlns:p="http://schemas.openxmlformats.org/presentationml/2006/main" xmlns:a="http://schemas.openxmlformats.org/drawingml/2006/main" xmlns:r="http://schemas.openxmlformats.org/officeDocument/2006/relationships">
   <p:cSld>
     <p:bg>
@@ -8114,7 +8373,7 @@
 </p:sld>
 </file>
 
-<file path=ppt/slides/slide23.xml><?xml version="1.0" encoding="utf-8"?>
+<file path=ppt/slides/slide24.xml><?xml version="1.0" encoding="utf-8"?>
 <p:sld xmlns:p="http://schemas.openxmlformats.org/presentationml/2006/main" xmlns:a="http://schemas.openxmlformats.org/drawingml/2006/main" xmlns:r="http://schemas.openxmlformats.org/officeDocument/2006/relationships">
   <p:cSld>
     <p:bg>
@@ -8450,7 +8709,7 @@
 </p:sld>
 </file>
 
-<file path=ppt/slides/slide24.xml><?xml version="1.0" encoding="utf-8"?>
+<file path=ppt/slides/slide25.xml><?xml version="1.0" encoding="utf-8"?>
 <p:sld xmlns:p="http://schemas.openxmlformats.org/presentationml/2006/main" xmlns:a="http://schemas.openxmlformats.org/drawingml/2006/main" xmlns:r="http://schemas.openxmlformats.org/officeDocument/2006/relationships">
   <p:cSld>
     <p:bg>

</xml_diff>